<commit_message>
Exploring Our Data: add a cell to show the table viewer
</commit_message>
<xml_diff>
--- a/slides/02_Exploring_Our_Data.pptx
+++ b/slides/02_Exploring_Our_Data.pptx
@@ -37,9 +37,10 @@
     <p:sldId id="285" r:id="rId31"/>
     <p:sldId id="286" r:id="rId32"/>
     <p:sldId id="287" r:id="rId33"/>
+    <p:sldId id="288" r:id="rId34"/>
   </p:sldIdLst>
   <p:notesMasterIdLst>
-    <p:notesMasterId r:id="rId34"/>
+    <p:notesMasterId r:id="rId35"/>
   </p:notesMasterIdLst>
   <p:sldSz cx="9144000" cy="5143500"/>
   <p:notesSz cx="5143500" cy="9144000"/>
@@ -138,7 +139,7 @@
   <p:extLst>
     <p:ext uri="{521415D9-36F7-43E2-AB2F-B90AF26B5E84}">
       <p14:sectionLst xmlns:p14="http://schemas.microsoft.com/office/powerpoint/2010/main">
-        <p14:section name="Introduction" id="{04e42105-5e48-8f3b-40be-28853d7fdc93}">
+        <p14:section name="Introduction" id="{d37e50e1-c286-5066-d605-e1d589b93c28}">
           <p14:sldIdLst>
             <p14:sldId id="256"/>
             <p14:sldId id="257"/>
@@ -147,7 +148,7 @@
             <p14:sldId id="260"/>
           </p14:sldIdLst>
         </p14:section>
-        <p14:section name="Notebooks and cells" id="{ce8a7632-711e-ff44-1bdb-0764a3879c29}">
+        <p14:section name="Notebooks and cells" id="{284a81c6-adfd-fff3-d8ba-2b2fabd2fa17}">
           <p14:sldIdLst>
             <p14:sldId id="261"/>
             <p14:sldId id="262"/>
@@ -155,26 +156,26 @@
             <p14:sldId id="264"/>
           </p14:sldIdLst>
         </p14:section>
-        <p14:section name="Import Polars" id="{03b8ccea-c216-11f9-69d3-141fa5361b0c}">
+        <p14:section name="Import Polars" id="{5855ee4d-93bb-20c1-c36c-cef24c30460a}">
           <p14:sldIdLst>
             <p14:sldId id="265"/>
             <p14:sldId id="266"/>
           </p14:sldIdLst>
         </p14:section>
-        <p14:section name="Load the data" id="{5fd0a0a4-2043-99b6-38a2-21705fb413d6}">
+        <p14:section name="Load the data" id="{bc61788b-970f-b4e0-810f-f2bac39f2637}">
           <p14:sldIdLst>
             <p14:sldId id="267"/>
             <p14:sldId id="268"/>
             <p14:sldId id="269"/>
           </p14:sldIdLst>
         </p14:section>
-        <p14:section name="How big is our data?" id="{16fcd5c4-9c8c-5e9d-166a-dd1252392d24}">
+        <p14:section name="How big is our data?" id="{6891dde6-777b-8665-231e-d99339fa3c02}">
           <p14:sldIdLst>
             <p14:sldId id="270"/>
             <p14:sldId id="271"/>
           </p14:sldIdLst>
         </p14:section>
-        <p14:section name="What kind of data is in each column?" id="{5d36351a-08ed-1c9e-2356-4147c11b066b}">
+        <p14:section name="What kind of data is in each column?" id="{240d5517-917e-1154-a471-0852410e0b98}">
           <p14:sldIdLst>
             <p14:sldId id="272"/>
             <p14:sldId id="273"/>
@@ -184,7 +185,7 @@
             <p14:sldId id="277"/>
           </p14:sldIdLst>
         </p14:section>
-        <p14:section name="Reactive cells" id="{5fa6632d-43b4-54b0-9412-98b97b4f8a96}">
+        <p14:section name="Reactive cells" id="{a21a4935-abed-81e4-2b5f-e5bb4e02803c}">
           <p14:sldIdLst>
             <p14:sldId id="278"/>
             <p14:sldId id="279"/>
@@ -193,17 +194,18 @@
             <p14:sldId id="282"/>
           </p14:sldIdLst>
         </p14:section>
-        <p14:section name="Exploring with the table viewer" id="{88472f26-46a1-bed6-e332-fa37e93a48a7}">
+        <p14:section name="Exploring with the table viewer" id="{49fef23b-a406-ee23-4224-93444fa163a5}">
           <p14:sldIdLst>
             <p14:sldId id="283"/>
             <p14:sldId id="284"/>
             <p14:sldId id="285"/>
+            <p14:sldId id="286"/>
           </p14:sldIdLst>
         </p14:section>
-        <p14:section name="Wrap up" id="{ee61534c-22b8-dc40-8d33-79550d126d52}">
+        <p14:section name="Wrap up" id="{7d9f2520-65b2-7dc9-529f-79d45a9ba55c}">
           <p14:sldIdLst>
-            <p14:sldId id="286"/>
             <p14:sldId id="287"/>
+            <p14:sldId id="288"/>
           </p14:sldIdLst>
         </p14:section>
       </p14:sectionLst>
@@ -2370,7 +2372,7 @@
           <a:p>
             <a:r>
               <a:rPr lang="en-US" dirty="0"/>
-              <a:t>Scroll back up to the games cell.</a:t>
+              <a:t>The table from loading games is now far up the notebook, and head only shows a few rows.</a:t>
             </a:r>
             <a:endParaRPr lang="en-US" dirty="0"/>
           </a:p>
@@ -2458,7 +2460,7 @@
           <a:p>
             <a:r>
               <a:rPr lang="en-US" dirty="0"/>
-              <a:t>Demonstrate each feature on the projector before students try the modify tasks.</a:t>
+              <a:t>Some students worry this breaks the one variable, one cell rule. It doesn't: showing a variable isn't creating it.</a:t>
             </a:r>
             <a:endParaRPr lang="en-US" dirty="0"/>
           </a:p>
@@ -2634,7 +2636,7 @@
           <a:p>
             <a:r>
               <a:rPr lang="en-US" dirty="0"/>
-              <a:t>Hollow Knight has 403,641 positive and 12,305 negative reviews. For task 3, don't give the answer yet: we look into those 0 scores next lesson. Free games really do cost 0.</a:t>
+              <a:t>Demonstrate each feature on the projector before students try the modify tasks.</a:t>
             </a:r>
             <a:endParaRPr lang="en-US" dirty="0"/>
           </a:p>
@@ -2722,13 +2724,7 @@
           <a:p>
             <a:r>
               <a:rPr lang="en-US" dirty="0"/>
-              <a:t>Cold-call or use mini whiteboards.
-Answers:
-1. Below its code.
-2. The number of rows (10,250 games) and columns (13).
-3. We can't sort text dates into the right order or work out which year a game came out.
-4. Changing a cell automatically re-runs every cell that uses its variables.
-5. Each variable can only be created in one cell, otherwise marimo can't tell which value it should have.</a:t>
+              <a:t>Hollow Knight has 403,641 positive and 12,305 negative reviews. For task 3, don't give the answer yet: we look into those 0 scores next lesson. Free games really do cost 0.</a:t>
             </a:r>
             <a:endParaRPr lang="en-US" dirty="0"/>
           </a:p>
@@ -2816,7 +2812,13 @@
           <a:p>
             <a:r>
               <a:rPr lang="en-US" dirty="0"/>
-              <a:t>Students use the table viewer for this. The strange things they note are clues for Behind the Scenes.</a:t>
+              <a:t>Cold-call or use mini whiteboards.
+Answers:
+1. Below its code.
+2. The number of rows (10,250 games) and columns (13).
+3. We can't sort text dates into the right order or work out which year a game came out.
+4. Changing a cell automatically re-runs every cell that uses its variables.
+5. Each variable can only be created in one cell, otherwise marimo can't tell which value it should have.</a:t>
             </a:r>
             <a:endParaRPr lang="en-US" dirty="0"/>
           </a:p>
@@ -2840,6 +2842,94 @@
             <a:fld id="{F7021451-1387-4CA6-816F-3879F97B5CBC}" type="slidenum">
               <a:rPr lang="en-US"/>
               <a:t>32</a:t>
+            </a:fld>
+            <a:endParaRPr lang="en-US"/>
+          </a:p>
+        </p:txBody>
+      </p:sp>
+    </p:spTree>
+    <p:extLst>
+      <p:ext uri="{BB962C8B-B14F-4D97-AF65-F5344CB8AC3E}">
+        <p14:creationId xmlns:p14="http://schemas.microsoft.com/office/powerpoint/2010/main" val="1024086991"/>
+      </p:ext>
+    </p:extLst>
+  </p:cSld>
+  <p:clrMapOvr>
+    <a:masterClrMapping/>
+  </p:clrMapOvr>
+</p:notes>
+</file>
+
+<file path=ppt/notesSlides/notesSlide33.xml><?xml version="1.0" encoding="utf-8"?>
+<p:notes xmlns:a="http://schemas.openxmlformats.org/drawingml/2006/main" xmlns:r="http://schemas.openxmlformats.org/officeDocument/2006/relationships" xmlns:p="http://schemas.openxmlformats.org/presentationml/2006/main">
+  <p:cSld>
+    <p:spTree>
+      <p:nvGrpSpPr>
+        <p:cNvPr id="1" name=""/>
+        <p:cNvGrpSpPr/>
+        <p:nvPr/>
+      </p:nvGrpSpPr>
+      <p:grpSpPr>
+        <a:xfrm>
+          <a:off x="0" y="0"/>
+          <a:ext cx="0" cy="0"/>
+          <a:chOff x="0" y="0"/>
+          <a:chExt cx="0" cy="0"/>
+        </a:xfrm>
+      </p:grpSpPr>
+      <p:sp>
+        <p:nvSpPr>
+          <p:cNvPr id="2" name="Slide Image Placeholder 1"/>
+          <p:cNvSpPr>
+            <a:spLocks noGrp="1" noRot="1" noChangeAspect="1"/>
+          </p:cNvSpPr>
+          <p:nvPr>
+            <p:ph type="sldImg"/>
+          </p:nvPr>
+        </p:nvSpPr>
+        <p:spPr/>
+      </p:sp>
+      <p:sp>
+        <p:nvSpPr>
+          <p:cNvPr id="3" name="Notes Placeholder 2"/>
+          <p:cNvSpPr>
+            <a:spLocks noGrp="1"/>
+          </p:cNvSpPr>
+          <p:nvPr>
+            <p:ph type="body" idx="1"/>
+          </p:nvPr>
+        </p:nvSpPr>
+        <p:spPr/>
+        <p:txBody>
+          <a:bodyPr/>
+          <a:lstStyle/>
+          <a:p>
+            <a:r>
+              <a:rPr lang="en-US" dirty="0"/>
+              <a:t>Students use the table viewer for this. The strange things they note are clues for Behind the Scenes.</a:t>
+            </a:r>
+            <a:endParaRPr lang="en-US" dirty="0"/>
+          </a:p>
+        </p:txBody>
+      </p:sp>
+      <p:sp>
+        <p:nvSpPr>
+          <p:cNvPr id="4" name="Slide Number Placeholder 3"/>
+          <p:cNvSpPr>
+            <a:spLocks noGrp="1"/>
+          </p:cNvSpPr>
+          <p:nvPr>
+            <p:ph type="sldNum" sz="quarter" idx="10"/>
+          </p:nvPr>
+        </p:nvSpPr>
+        <p:spPr/>
+        <p:txBody>
+          <a:bodyPr/>
+          <a:lstStyle/>
+          <a:p>
+            <a:fld id="{F7021451-1387-4CA6-816F-3879F97B5CBC}" type="slidenum">
+              <a:rPr lang="en-US"/>
+              <a:t>33</a:t>
             </a:fld>
             <a:endParaRPr lang="en-US"/>
           </a:p>
@@ -11808,7 +11898,7 @@
                   <a:srgbClr val="F7EFE6"/>
                 </a:solidFill>
               </a:rPr>
-              <a:t>The table marimo shows for </a:t>
+              <a:t>To explore the whole dataset, we bring the full </a:t>
             </a:r>
             <a:r>
               <a:rPr lang="en-US" sz="1600" b="1" dirty="0">
@@ -11827,7 +11917,7 @@
                   <a:srgbClr val="F7EFE6"/>
                 </a:solidFill>
               </a:rPr>
-              <a:t> isn't just a picture: it's a tool for exploring.</a:t>
+              <a:t> table back right here.</a:t>
             </a:r>
             <a:endParaRPr lang="en-US" sz="1800" dirty="0"/>
           </a:p>
@@ -11935,7 +12025,7 @@
                   <a:srgbClr val="4E342E"/>
                 </a:solidFill>
               </a:rPr>
-              <a:t>What the table viewer can do</a:t>
+              <a:t>Show the whole table again</a:t>
             </a:r>
             <a:endParaRPr lang="en-US" sz="2800" dirty="0"/>
           </a:p>
@@ -11943,14 +12033,215 @@
       </p:sp>
       <p:sp>
         <p:nvSpPr>
-          <p:cNvPr id="3" name="Text 1"/>
+          <p:cNvPr id="3" name="Code panel"/>
+          <p:cNvSpPr/>
+          <p:nvPr/>
+        </p:nvSpPr>
+        <p:spPr>
+          <a:xfrm>
+            <a:off x="457200" y="1051560"/>
+            <a:ext cx="3840480" cy="786765"/>
+          </a:xfrm>
+          <a:prstGeom prst="roundRect">
+            <a:avLst>
+              <a:gd name="adj" fmla="val 6973"/>
+            </a:avLst>
+          </a:prstGeom>
+          <a:solidFill>
+            <a:srgbClr val="2B1D19"/>
+          </a:solidFill>
+          <a:ln w="12700">
+            <a:solidFill>
+              <a:srgbClr val="2B1D19"/>
+            </a:solidFill>
+            <a:prstDash val="solid"/>
+          </a:ln>
+        </p:spPr>
+      </p:sp>
+      <p:sp>
+        <p:nvSpPr>
+          <p:cNvPr id="4" name="Text 2"/>
           <p:cNvSpPr txBox="1"/>
           <p:nvPr/>
         </p:nvSpPr>
         <p:spPr>
           <a:xfrm>
-            <a:off x="457200" y="1097280"/>
-            <a:ext cx="8229600" cy="3383280"/>
+            <a:off x="640080" y="1161288"/>
+            <a:ext cx="3474720" cy="274320"/>
+          </a:xfrm>
+          <a:prstGeom prst="rect">
+            <a:avLst/>
+          </a:prstGeom>
+          <a:noFill/>
+          <a:ln/>
+        </p:spPr>
+        <p:txBody>
+          <a:bodyPr wrap="square" lIns="0" tIns="0" rIns="0" bIns="0" rtlCol="0" anchor="ctr"/>
+          <a:lstStyle/>
+          <a:p>
+            <a:pPr indent="0" marL="0">
+              <a:buNone/>
+            </a:pPr>
+            <a:r>
+              <a:rPr lang="en-US" sz="1200" b="1" dirty="0">
+                <a:solidFill>
+                  <a:srgbClr val="E8A55A"/>
+                </a:solidFill>
+              </a:rPr>
+              <a:t>clean_steam.py — new cell</a:t>
+            </a:r>
+            <a:endParaRPr lang="en-US" sz="1200" dirty="0"/>
+          </a:p>
+        </p:txBody>
+      </p:sp>
+      <p:sp>
+        <p:nvSpPr>
+          <p:cNvPr id="5" name="Code"/>
+          <p:cNvSpPr txBox="1"/>
+          <p:nvPr/>
+        </p:nvSpPr>
+        <p:spPr>
+          <a:xfrm>
+            <a:off x="594360" y="1508760"/>
+            <a:ext cx="3566160" cy="267970"/>
+          </a:xfrm>
+          <a:prstGeom prst="rect">
+            <a:avLst/>
+          </a:prstGeom>
+          <a:noFill/>
+          <a:ln/>
+        </p:spPr>
+        <p:txBody>
+          <a:bodyPr wrap="square" lIns="0" tIns="0" rIns="0" bIns="0" rtlCol="0" anchor="t"/>
+          <a:lstStyle/>
+          <a:p>
+            <a:pPr indent="0" marL="0">
+              <a:lnSpc>
+                <a:spcPts val="1750"/>
+              </a:lnSpc>
+              <a:buNone/>
+            </a:pPr>
+            <a:r>
+              <a:rPr lang="en-US" sz="1400" dirty="0">
+                <a:solidFill>
+                  <a:srgbClr val="9C8A80"/>
+                </a:solidFill>
+                <a:latin typeface="Courier New" pitchFamily="34" charset="0"/>
+                <a:ea typeface="Courier New" pitchFamily="34" charset="-122"/>
+                <a:cs typeface="Courier New" pitchFamily="34" charset="-120"/>
+              </a:rPr>
+              <a:t> 1  </a:t>
+            </a:r>
+            <a:r>
+              <a:rPr lang="en-US" sz="1400" dirty="0">
+                <a:solidFill>
+                  <a:srgbClr val="F7EFE6"/>
+                </a:solidFill>
+                <a:latin typeface="Courier New" pitchFamily="34" charset="0"/>
+                <a:ea typeface="Courier New" pitchFamily="34" charset="-122"/>
+                <a:cs typeface="Courier New" pitchFamily="34" charset="-120"/>
+              </a:rPr>
+              <a:t>games</a:t>
+            </a:r>
+            <a:endParaRPr lang="en-US" sz="1400" dirty="0"/>
+          </a:p>
+        </p:txBody>
+      </p:sp>
+      <p:sp>
+        <p:nvSpPr>
+          <p:cNvPr id="6" name="Text 4"/>
+          <p:cNvSpPr txBox="1"/>
+          <p:nvPr/>
+        </p:nvSpPr>
+        <p:spPr>
+          <a:xfrm>
+            <a:off x="457200" y="1929765"/>
+            <a:ext cx="3840480" cy="384048"/>
+          </a:xfrm>
+          <a:prstGeom prst="rect">
+            <a:avLst/>
+          </a:prstGeom>
+          <a:noFill/>
+          <a:ln/>
+        </p:spPr>
+        <p:txBody>
+          <a:bodyPr wrap="square" lIns="0" tIns="0" rIns="0" bIns="0" rtlCol="0" anchor="ctr">
+            <a:normAutofit/>
+          </a:bodyPr>
+          <a:lstStyle/>
+          <a:p>
+            <a:pPr indent="0" marL="0">
+              <a:spcAft>
+                <a:spcPts val="800"/>
+              </a:spcAft>
+              <a:buNone/>
+            </a:pPr>
+            <a:r>
+              <a:rPr lang="en-US" sz="1500" dirty="0">
+                <a:solidFill>
+                  <a:srgbClr val="2B1D19"/>
+                </a:solidFill>
+              </a:rPr>
+              <a:t>​</a:t>
+            </a:r>
+            <a:r>
+              <a:rPr lang="en-US" sz="1500" dirty="0">
+                <a:solidFill>
+                  <a:srgbClr val="2B1D19"/>
+                </a:solidFill>
+              </a:rPr>
+              <a:t>All 10,250 games appear in the table viewer below the cell.</a:t>
+            </a:r>
+            <a:endParaRPr lang="en-US" sz="1500" dirty="0"/>
+          </a:p>
+        </p:txBody>
+      </p:sp>
+      <p:sp>
+        <p:nvSpPr>
+          <p:cNvPr id="7" name="Text 5"/>
+          <p:cNvSpPr txBox="1"/>
+          <p:nvPr/>
+        </p:nvSpPr>
+        <p:spPr>
+          <a:xfrm>
+            <a:off x="4572000" y="1051560"/>
+            <a:ext cx="4114800" cy="320040"/>
+          </a:xfrm>
+          <a:prstGeom prst="rect">
+            <a:avLst/>
+          </a:prstGeom>
+          <a:noFill/>
+          <a:ln/>
+        </p:spPr>
+        <p:txBody>
+          <a:bodyPr wrap="square" lIns="0" tIns="0" rIns="0" bIns="0" rtlCol="0" anchor="ctr"/>
+          <a:lstStyle/>
+          <a:p>
+            <a:pPr indent="0" marL="0">
+              <a:buNone/>
+            </a:pPr>
+            <a:r>
+              <a:rPr lang="en-US" sz="1400" b="1" dirty="0">
+                <a:solidFill>
+                  <a:srgbClr val="B86E1E"/>
+                </a:solidFill>
+              </a:rPr>
+              <a:t>Why</a:t>
+            </a:r>
+            <a:endParaRPr lang="en-US" sz="1400" dirty="0"/>
+          </a:p>
+        </p:txBody>
+      </p:sp>
+      <p:sp>
+        <p:nvSpPr>
+          <p:cNvPr id="8" name="Text 6"/>
+          <p:cNvSpPr txBox="1"/>
+          <p:nvPr/>
+        </p:nvSpPr>
+        <p:spPr>
+          <a:xfrm>
+            <a:off x="4572000" y="1399032"/>
+            <a:ext cx="4114800" cy="3017520"/>
           </a:xfrm>
           <a:prstGeom prst="rect">
             <a:avLst/>
@@ -11964,15 +12255,14 @@
           </a:bodyPr>
           <a:lstStyle/>
           <a:p>
-            <a:pPr marL="342900" indent="-342900">
+            <a:pPr indent="0" marL="0">
               <a:spcAft>
                 <a:spcPts val="800"/>
               </a:spcAft>
-              <a:buSzPct val="100000"/>
-              <a:buChar char="•"/>
-            </a:pPr>
-            <a:r>
-              <a:rPr lang="en-US" sz="1700" dirty="0">
+              <a:buNone/>
+            </a:pPr>
+            <a:r>
+              <a:rPr lang="en-US" sz="1500" dirty="0">
                 <a:solidFill>
                   <a:srgbClr val="2B1D19"/>
                 </a:solidFill>
@@ -11980,124 +12270,33 @@
               <a:t>​</a:t>
             </a:r>
             <a:r>
-              <a:rPr lang="en-US" sz="1700" b="1" dirty="0">
-                <a:solidFill>
-                  <a:srgbClr val="2B1D19"/>
-                </a:solidFill>
-              </a:rPr>
-              <a:t>scroll</a:t>
-            </a:r>
-            <a:r>
-              <a:rPr lang="en-US" sz="1700" dirty="0">
-                <a:solidFill>
-                  <a:srgbClr val="2B1D19"/>
-                </a:solidFill>
-              </a:rPr>
-              <a:t> across all 13 columns; page buttons move through the rows</a:t>
-            </a:r>
-            <a:endParaRPr lang="en-US" sz="1700" dirty="0"/>
-          </a:p>
-          <a:p>
-            <a:pPr marL="342900" indent="-342900">
-              <a:spcAft>
-                <a:spcPts val="800"/>
-              </a:spcAft>
-              <a:buSzPct val="100000"/>
-              <a:buChar char="•"/>
-            </a:pPr>
-            <a:r>
-              <a:rPr lang="en-US" sz="1700" dirty="0">
-                <a:solidFill>
-                  <a:srgbClr val="2B1D19"/>
-                </a:solidFill>
-              </a:rPr>
-              <a:t>​</a:t>
-            </a:r>
-            <a:r>
-              <a:rPr lang="en-US" sz="1700" b="1" dirty="0">
-                <a:solidFill>
-                  <a:srgbClr val="2B1D19"/>
-                </a:solidFill>
-              </a:rPr>
-              <a:t>sort</a:t>
-            </a:r>
-            <a:r>
-              <a:rPr lang="en-US" sz="1700" dirty="0">
-                <a:solidFill>
-                  <a:srgbClr val="2B1D19"/>
-                </a:solidFill>
-              </a:rPr>
-              <a:t> by a column, by clicking its heading</a:t>
-            </a:r>
-            <a:endParaRPr lang="en-US" sz="1700" dirty="0"/>
-          </a:p>
-          <a:p>
-            <a:pPr marL="342900" indent="-342900">
-              <a:spcAft>
-                <a:spcPts val="800"/>
-              </a:spcAft>
-              <a:buSzPct val="100000"/>
-              <a:buChar char="•"/>
-            </a:pPr>
-            <a:r>
-              <a:rPr lang="en-US" sz="1700" dirty="0">
-                <a:solidFill>
-                  <a:srgbClr val="2B1D19"/>
-                </a:solidFill>
-              </a:rPr>
-              <a:t>​</a:t>
-            </a:r>
-            <a:r>
-              <a:rPr lang="en-US" sz="1700" b="1" dirty="0">
-                <a:solidFill>
-                  <a:srgbClr val="2B1D19"/>
-                </a:solidFill>
-              </a:rPr>
-              <a:t>search</a:t>
-            </a:r>
-            <a:r>
-              <a:rPr lang="en-US" sz="1700" dirty="0">
-                <a:solidFill>
-                  <a:srgbClr val="2B1D19"/>
-                </a:solidFill>
-              </a:rPr>
-              <a:t> for a value, using the search box above the table</a:t>
-            </a:r>
-            <a:endParaRPr lang="en-US" sz="1700" dirty="0"/>
-          </a:p>
-          <a:p>
-            <a:pPr marL="342900" indent="-342900">
-              <a:spcAft>
-                <a:spcPts val="800"/>
-              </a:spcAft>
-              <a:buSzPct val="100000"/>
-              <a:buChar char="•"/>
-            </a:pPr>
-            <a:r>
-              <a:rPr lang="en-US" sz="1700" dirty="0">
-                <a:solidFill>
-                  <a:srgbClr val="2B1D19"/>
-                </a:solidFill>
-              </a:rPr>
-              <a:t>​</a:t>
-            </a:r>
-            <a:r>
-              <a:rPr lang="en-US" sz="1700" b="1" dirty="0">
-                <a:solidFill>
-                  <a:srgbClr val="2B1D19"/>
-                </a:solidFill>
-              </a:rPr>
-              <a:t>see a summary</a:t>
-            </a:r>
-            <a:r>
-              <a:rPr lang="en-US" sz="1700" dirty="0">
-                <a:solidFill>
-                  <a:srgbClr val="2B1D19"/>
-                </a:solidFill>
-              </a:rPr>
-              <a:t> of a column, such as its smallest and largest values</a:t>
-            </a:r>
-            <a:endParaRPr lang="en-US" sz="1700" dirty="0"/>
+              <a:rPr lang="en-US" sz="1500" dirty="0">
+                <a:solidFill>
+                  <a:srgbClr val="2B1D19"/>
+                </a:solidFill>
+              </a:rPr>
+              <a:t>A cell's output is the value of its last line, so a cell holding just </a:t>
+            </a:r>
+            <a:r>
+              <a:rPr lang="en-US" sz="1300" b="1" dirty="0">
+                <a:solidFill>
+                  <a:srgbClr val="B86E1E"/>
+                </a:solidFill>
+                <a:latin typeface="Courier New" pitchFamily="34" charset="0"/>
+                <a:ea typeface="Courier New" pitchFamily="34" charset="-122"/>
+                <a:cs typeface="Courier New" pitchFamily="34" charset="-120"/>
+              </a:rPr>
+              <a:t>games</a:t>
+            </a:r>
+            <a:r>
+              <a:rPr lang="en-US" sz="1500" dirty="0">
+                <a:solidFill>
+                  <a:srgbClr val="2B1D19"/>
+                </a:solidFill>
+              </a:rPr>
+              <a:t> shows the whole DataFrame. It doesn't create a variable, so marimo is happy for it to be in another cell.</a:t>
+            </a:r>
+            <a:endParaRPr lang="en-US" sz="1500" dirty="0"/>
           </a:p>
         </p:txBody>
       </p:sp>
@@ -12534,7 +12733,7 @@
                   <a:srgbClr val="4E342E"/>
                 </a:solidFill>
               </a:rPr>
-              <a:t>Explore with the table viewer</a:t>
+              <a:t>What the table viewer can do</a:t>
             </a:r>
             <a:endParaRPr lang="en-US" sz="2800" dirty="0"/>
           </a:p>
@@ -12542,77 +12741,14 @@
       </p:sp>
       <p:sp>
         <p:nvSpPr>
-          <p:cNvPr id="3" name="primm box"/>
-          <p:cNvSpPr/>
-          <p:nvPr/>
-        </p:nvSpPr>
-        <p:spPr>
-          <a:xfrm>
-            <a:off x="457200" y="1051560"/>
-            <a:ext cx="8229600" cy="3078480"/>
-          </a:xfrm>
-          <a:prstGeom prst="roundRect">
-            <a:avLst>
-              <a:gd name="adj" fmla="val 2376"/>
-            </a:avLst>
-          </a:prstGeom>
-          <a:solidFill>
-            <a:srgbClr val="E6F2E6"/>
-          </a:solidFill>
-          <a:ln w="12700">
-            <a:solidFill>
-              <a:srgbClr val="E6F2E6"/>
-            </a:solidFill>
-            <a:prstDash val="solid"/>
-          </a:ln>
-        </p:spPr>
-      </p:sp>
-      <p:sp>
-        <p:nvSpPr>
-          <p:cNvPr id="4" name="Text 2"/>
+          <p:cNvPr id="3" name="Text 1"/>
           <p:cNvSpPr txBox="1"/>
           <p:nvPr/>
         </p:nvSpPr>
         <p:spPr>
           <a:xfrm>
-            <a:off x="685800" y="1188720"/>
-            <a:ext cx="7772400" cy="365760"/>
-          </a:xfrm>
-          <a:prstGeom prst="rect">
-            <a:avLst/>
-          </a:prstGeom>
-          <a:noFill/>
-          <a:ln/>
-        </p:spPr>
-        <p:txBody>
-          <a:bodyPr wrap="square" lIns="0" tIns="0" rIns="0" bIns="0" rtlCol="0" anchor="ctr"/>
-          <a:lstStyle/>
-          <a:p>
-            <a:pPr indent="0" marL="0">
-              <a:buNone/>
-            </a:pPr>
-            <a:r>
-              <a:rPr lang="en-US" sz="1600" b="1" dirty="0">
-                <a:solidFill>
-                  <a:srgbClr val="2E6B30"/>
-                </a:solidFill>
-              </a:rPr>
-              <a:t>PRIMM</a:t>
-            </a:r>
-            <a:endParaRPr lang="en-US" sz="1600" dirty="0"/>
-          </a:p>
-        </p:txBody>
-      </p:sp>
-      <p:sp>
-        <p:nvSpPr>
-          <p:cNvPr id="5" name="Text 3"/>
-          <p:cNvSpPr txBox="1"/>
-          <p:nvPr/>
-        </p:nvSpPr>
-        <p:spPr>
-          <a:xfrm>
-            <a:off x="685800" y="1600200"/>
-            <a:ext cx="7772400" cy="2392680"/>
+            <a:off x="457200" y="1097280"/>
+            <a:ext cx="8229600" cy="3383280"/>
           </a:xfrm>
           <a:prstGeom prst="rect">
             <a:avLst/>
@@ -12628,14 +12764,13 @@
           <a:p>
             <a:pPr marL="342900" indent="-342900">
               <a:spcAft>
-                <a:spcPts val="1000"/>
+                <a:spcPts val="800"/>
               </a:spcAft>
               <a:buSzPct val="100000"/>
-              <a:buFont typeface="+mj-lt"/>
-              <a:buAutoNum type="arabicPeriod" startAt="1"/>
-            </a:pPr>
-            <a:r>
-              <a:rPr lang="en-US" sz="2000" dirty="0">
+              <a:buChar char="•"/>
+            </a:pPr>
+            <a:r>
+              <a:rPr lang="en-US" sz="1700" dirty="0">
                 <a:solidFill>
                   <a:srgbClr val="2B1D19"/>
                 </a:solidFill>
@@ -12643,45 +12778,33 @@
               <a:t>​</a:t>
             </a:r>
             <a:r>
-              <a:rPr lang="en-US" sz="2000" dirty="0">
-                <a:solidFill>
-                  <a:srgbClr val="2B1D19"/>
-                </a:solidFill>
-              </a:rPr>
-              <a:t>Sort by </a:t>
-            </a:r>
-            <a:r>
-              <a:rPr lang="en-US" sz="1800" b="1" dirty="0">
-                <a:solidFill>
-                  <a:srgbClr val="B86E1E"/>
-                </a:solidFill>
-                <a:latin typeface="Courier New" pitchFamily="34" charset="0"/>
-                <a:ea typeface="Courier New" pitchFamily="34" charset="-122"/>
-                <a:cs typeface="Courier New" pitchFamily="34" charset="-120"/>
-              </a:rPr>
-              <a:t>Price</a:t>
-            </a:r>
-            <a:r>
-              <a:rPr lang="en-US" sz="2000" dirty="0">
-                <a:solidFill>
-                  <a:srgbClr val="2B1D19"/>
-                </a:solidFill>
-              </a:rPr>
-              <a:t>, highest then lowest. What do the games that cost 0 have in common?</a:t>
-            </a:r>
-            <a:endParaRPr lang="en-US" sz="2000" dirty="0"/>
+              <a:rPr lang="en-US" sz="1700" b="1" dirty="0">
+                <a:solidFill>
+                  <a:srgbClr val="2B1D19"/>
+                </a:solidFill>
+              </a:rPr>
+              <a:t>scroll</a:t>
+            </a:r>
+            <a:r>
+              <a:rPr lang="en-US" sz="1700" dirty="0">
+                <a:solidFill>
+                  <a:srgbClr val="2B1D19"/>
+                </a:solidFill>
+              </a:rPr>
+              <a:t> across all 13 columns; page buttons move through the rows</a:t>
+            </a:r>
+            <a:endParaRPr lang="en-US" sz="1700" dirty="0"/>
           </a:p>
           <a:p>
             <a:pPr marL="342900" indent="-342900">
               <a:spcAft>
-                <a:spcPts val="1000"/>
+                <a:spcPts val="800"/>
               </a:spcAft>
               <a:buSzPct val="100000"/>
-              <a:buFont typeface="+mj-lt"/>
-              <a:buAutoNum type="arabicPeriod" startAt="1"/>
-            </a:pPr>
-            <a:r>
-              <a:rPr lang="en-US" sz="2000" dirty="0">
+              <a:buChar char="•"/>
+            </a:pPr>
+            <a:r>
+              <a:rPr lang="en-US" sz="1700" dirty="0">
                 <a:solidFill>
                   <a:srgbClr val="2B1D19"/>
                 </a:solidFill>
@@ -12689,45 +12812,33 @@
               <a:t>​</a:t>
             </a:r>
             <a:r>
-              <a:rPr lang="en-US" sz="2000" dirty="0">
-                <a:solidFill>
-                  <a:srgbClr val="2B1D19"/>
-                </a:solidFill>
-              </a:rPr>
-              <a:t>Search for </a:t>
-            </a:r>
-            <a:r>
-              <a:rPr lang="en-US" sz="1800" b="1" dirty="0">
-                <a:solidFill>
-                  <a:srgbClr val="B86E1E"/>
-                </a:solidFill>
-                <a:latin typeface="Courier New" pitchFamily="34" charset="0"/>
-                <a:ea typeface="Courier New" pitchFamily="34" charset="-122"/>
-                <a:cs typeface="Courier New" pitchFamily="34" charset="-120"/>
-              </a:rPr>
-              <a:t>Hollow Knight</a:t>
-            </a:r>
-            <a:r>
-              <a:rPr lang="en-US" sz="2000" dirty="0">
-                <a:solidFill>
-                  <a:srgbClr val="2B1D19"/>
-                </a:solidFill>
-              </a:rPr>
-              <a:t>. How would we work out what share of its reviews are positive?</a:t>
-            </a:r>
-            <a:endParaRPr lang="en-US" sz="2000" dirty="0"/>
+              <a:rPr lang="en-US" sz="1700" b="1" dirty="0">
+                <a:solidFill>
+                  <a:srgbClr val="2B1D19"/>
+                </a:solidFill>
+              </a:rPr>
+              <a:t>sort</a:t>
+            </a:r>
+            <a:r>
+              <a:rPr lang="en-US" sz="1700" dirty="0">
+                <a:solidFill>
+                  <a:srgbClr val="2B1D19"/>
+                </a:solidFill>
+              </a:rPr>
+              <a:t> by a column, by clicking its heading</a:t>
+            </a:r>
+            <a:endParaRPr lang="en-US" sz="1700" dirty="0"/>
           </a:p>
           <a:p>
             <a:pPr marL="342900" indent="-342900">
               <a:spcAft>
-                <a:spcPts val="1000"/>
+                <a:spcPts val="800"/>
               </a:spcAft>
               <a:buSzPct val="100000"/>
-              <a:buFont typeface="+mj-lt"/>
-              <a:buAutoNum type="arabicPeriod" startAt="1"/>
-            </a:pPr>
-            <a:r>
-              <a:rPr lang="en-US" sz="2000" dirty="0">
+              <a:buChar char="•"/>
+            </a:pPr>
+            <a:r>
+              <a:rPr lang="en-US" sz="1700" dirty="0">
                 <a:solidFill>
                   <a:srgbClr val="2B1D19"/>
                 </a:solidFill>
@@ -12735,33 +12846,56 @@
               <a:t>​</a:t>
             </a:r>
             <a:r>
-              <a:rPr lang="en-US" sz="2000" dirty="0">
-                <a:solidFill>
-                  <a:srgbClr val="2B1D19"/>
-                </a:solidFill>
-              </a:rPr>
-              <a:t>Sort by </a:t>
-            </a:r>
-            <a:r>
-              <a:rPr lang="en-US" sz="1800" b="1" dirty="0">
-                <a:solidFill>
-                  <a:srgbClr val="B86E1E"/>
-                </a:solidFill>
-                <a:latin typeface="Courier New" pitchFamily="34" charset="0"/>
-                <a:ea typeface="Courier New" pitchFamily="34" charset="-122"/>
-                <a:cs typeface="Courier New" pitchFamily="34" charset="-120"/>
-              </a:rPr>
-              <a:t>Metacritic score</a:t>
-            </a:r>
-            <a:r>
-              <a:rPr lang="en-US" sz="2000" dirty="0">
-                <a:solidFill>
-                  <a:srgbClr val="2B1D19"/>
-                </a:solidFill>
-              </a:rPr>
-              <a:t>. Are the games scoring 0 really that bad?</a:t>
-            </a:r>
-            <a:endParaRPr lang="en-US" sz="2000" dirty="0"/>
+              <a:rPr lang="en-US" sz="1700" b="1" dirty="0">
+                <a:solidFill>
+                  <a:srgbClr val="2B1D19"/>
+                </a:solidFill>
+              </a:rPr>
+              <a:t>search</a:t>
+            </a:r>
+            <a:r>
+              <a:rPr lang="en-US" sz="1700" dirty="0">
+                <a:solidFill>
+                  <a:srgbClr val="2B1D19"/>
+                </a:solidFill>
+              </a:rPr>
+              <a:t> for a value, using the search box above the table</a:t>
+            </a:r>
+            <a:endParaRPr lang="en-US" sz="1700" dirty="0"/>
+          </a:p>
+          <a:p>
+            <a:pPr marL="342900" indent="-342900">
+              <a:spcAft>
+                <a:spcPts val="800"/>
+              </a:spcAft>
+              <a:buSzPct val="100000"/>
+              <a:buChar char="•"/>
+            </a:pPr>
+            <a:r>
+              <a:rPr lang="en-US" sz="1700" dirty="0">
+                <a:solidFill>
+                  <a:srgbClr val="2B1D19"/>
+                </a:solidFill>
+              </a:rPr>
+              <a:t>​</a:t>
+            </a:r>
+            <a:r>
+              <a:rPr lang="en-US" sz="1700" b="1" dirty="0">
+                <a:solidFill>
+                  <a:srgbClr val="2B1D19"/>
+                </a:solidFill>
+              </a:rPr>
+              <a:t>see a summary</a:t>
+            </a:r>
+            <a:r>
+              <a:rPr lang="en-US" sz="1700" dirty="0">
+                <a:solidFill>
+                  <a:srgbClr val="2B1D19"/>
+                </a:solidFill>
+              </a:rPr>
+              <a:t> of a column, such as its smallest and largest values</a:t>
+            </a:r>
+            <a:endParaRPr lang="en-US" sz="1700" dirty="0"/>
           </a:p>
         </p:txBody>
       </p:sp>
@@ -12837,14 +12971,14 @@
       </p:grpSpPr>
       <p:sp>
         <p:nvSpPr>
-          <p:cNvPr id="2" name="Text 0"/>
+          <p:cNvPr id="2" name="Title"/>
           <p:cNvSpPr txBox="1"/>
           <p:nvPr/>
         </p:nvSpPr>
         <p:spPr>
           <a:xfrm>
-            <a:off x="457200" y="457200"/>
-            <a:ext cx="7772400" cy="365760"/>
+            <a:off x="457200" y="274320"/>
+            <a:ext cx="8229600" cy="640080"/>
           </a:xfrm>
           <a:prstGeom prst="rect">
             <a:avLst/>
@@ -12853,34 +12987,99 @@
           <a:ln/>
         </p:spPr>
         <p:txBody>
-          <a:bodyPr wrap="square" lIns="0" tIns="0" rIns="0" bIns="0" rtlCol="0" anchor="ctr"/>
+          <a:bodyPr wrap="square" lIns="0" tIns="0" rIns="0" bIns="0" rtlCol="0" anchor="ctr">
+            <a:normAutofit/>
+          </a:bodyPr>
           <a:lstStyle/>
           <a:p>
             <a:pPr indent="0" marL="0">
               <a:buNone/>
             </a:pPr>
             <a:r>
-              <a:rPr lang="en-US" sz="1400" b="1" spc="200" kern="0" dirty="0">
-                <a:solidFill>
-                  <a:srgbClr val="E8A55A"/>
-                </a:solidFill>
-              </a:rPr>
-              <a:t>CHECK YOUR UNDERSTANDING</a:t>
-            </a:r>
-            <a:endParaRPr lang="en-US" sz="1400" dirty="0"/>
-          </a:p>
-        </p:txBody>
-      </p:sp>
-      <p:sp>
-        <p:nvSpPr>
-          <p:cNvPr id="3" name="Text 1"/>
+              <a:rPr lang="en-US" sz="2800" b="1" dirty="0">
+                <a:solidFill>
+                  <a:srgbClr val="4E342E"/>
+                </a:solidFill>
+              </a:rPr>
+              <a:t>Explore with the table viewer</a:t>
+            </a:r>
+            <a:endParaRPr lang="en-US" sz="2800" dirty="0"/>
+          </a:p>
+        </p:txBody>
+      </p:sp>
+      <p:sp>
+        <p:nvSpPr>
+          <p:cNvPr id="3" name="primm box"/>
+          <p:cNvSpPr/>
+          <p:nvPr/>
+        </p:nvSpPr>
+        <p:spPr>
+          <a:xfrm>
+            <a:off x="457200" y="1051560"/>
+            <a:ext cx="8229600" cy="3078480"/>
+          </a:xfrm>
+          <a:prstGeom prst="roundRect">
+            <a:avLst>
+              <a:gd name="adj" fmla="val 2376"/>
+            </a:avLst>
+          </a:prstGeom>
+          <a:solidFill>
+            <a:srgbClr val="E6F2E6"/>
+          </a:solidFill>
+          <a:ln w="12700">
+            <a:solidFill>
+              <a:srgbClr val="E6F2E6"/>
+            </a:solidFill>
+            <a:prstDash val="solid"/>
+          </a:ln>
+        </p:spPr>
+      </p:sp>
+      <p:sp>
+        <p:nvSpPr>
+          <p:cNvPr id="4" name="Text 2"/>
           <p:cNvSpPr txBox="1"/>
           <p:nvPr/>
         </p:nvSpPr>
         <p:spPr>
           <a:xfrm>
-            <a:off x="457200" y="1005840"/>
-            <a:ext cx="7498080" cy="3108960"/>
+            <a:off x="685800" y="1188720"/>
+            <a:ext cx="7772400" cy="365760"/>
+          </a:xfrm>
+          <a:prstGeom prst="rect">
+            <a:avLst/>
+          </a:prstGeom>
+          <a:noFill/>
+          <a:ln/>
+        </p:spPr>
+        <p:txBody>
+          <a:bodyPr wrap="square" lIns="0" tIns="0" rIns="0" bIns="0" rtlCol="0" anchor="ctr"/>
+          <a:lstStyle/>
+          <a:p>
+            <a:pPr indent="0" marL="0">
+              <a:buNone/>
+            </a:pPr>
+            <a:r>
+              <a:rPr lang="en-US" sz="1600" b="1" dirty="0">
+                <a:solidFill>
+                  <a:srgbClr val="2E6B30"/>
+                </a:solidFill>
+              </a:rPr>
+              <a:t>PRIMM</a:t>
+            </a:r>
+            <a:endParaRPr lang="en-US" sz="1600" dirty="0"/>
+          </a:p>
+        </p:txBody>
+      </p:sp>
+      <p:sp>
+        <p:nvSpPr>
+          <p:cNvPr id="5" name="Text 3"/>
+          <p:cNvSpPr txBox="1"/>
+          <p:nvPr/>
+        </p:nvSpPr>
+        <p:spPr>
+          <a:xfrm>
+            <a:off x="685800" y="1600200"/>
+            <a:ext cx="7772400" cy="2392680"/>
           </a:xfrm>
           <a:prstGeom prst="rect">
             <a:avLst/>
@@ -12896,7 +13095,7 @@
           <a:p>
             <a:pPr marL="342900" indent="-342900">
               <a:spcAft>
-                <a:spcPts val="1400"/>
+                <a:spcPts val="1000"/>
               </a:spcAft>
               <a:buSzPct val="100000"/>
               <a:buFont typeface="+mj-lt"/>
@@ -12905,7 +13104,7 @@
             <a:r>
               <a:rPr lang="en-US" sz="2000" dirty="0">
                 <a:solidFill>
-                  <a:srgbClr val="FFFFFF"/>
+                  <a:srgbClr val="2B1D19"/>
                 </a:solidFill>
               </a:rPr>
               <a:t>​</a:t>
@@ -12913,17 +13112,36 @@
             <a:r>
               <a:rPr lang="en-US" sz="2000" dirty="0">
                 <a:solidFill>
-                  <a:srgbClr val="FFFFFF"/>
-                </a:solidFill>
-              </a:rPr>
-              <a:t>Where does a marimo cell's output appear?</a:t>
+                  <a:srgbClr val="2B1D19"/>
+                </a:solidFill>
+              </a:rPr>
+              <a:t>Sort by </a:t>
+            </a:r>
+            <a:r>
+              <a:rPr lang="en-US" sz="1800" b="1" dirty="0">
+                <a:solidFill>
+                  <a:srgbClr val="B86E1E"/>
+                </a:solidFill>
+                <a:latin typeface="Courier New" pitchFamily="34" charset="0"/>
+                <a:ea typeface="Courier New" pitchFamily="34" charset="-122"/>
+                <a:cs typeface="Courier New" pitchFamily="34" charset="-120"/>
+              </a:rPr>
+              <a:t>Price</a:t>
+            </a:r>
+            <a:r>
+              <a:rPr lang="en-US" sz="2000" dirty="0">
+                <a:solidFill>
+                  <a:srgbClr val="2B1D19"/>
+                </a:solidFill>
+              </a:rPr>
+              <a:t>, highest then lowest. What do the games that cost 0 have in common?</a:t>
             </a:r>
             <a:endParaRPr lang="en-US" sz="2000" dirty="0"/>
           </a:p>
           <a:p>
             <a:pPr marL="342900" indent="-342900">
               <a:spcAft>
-                <a:spcPts val="1400"/>
+                <a:spcPts val="1000"/>
               </a:spcAft>
               <a:buSzPct val="100000"/>
               <a:buFont typeface="+mj-lt"/>
@@ -12932,7 +13150,7 @@
             <a:r>
               <a:rPr lang="en-US" sz="2000" dirty="0">
                 <a:solidFill>
-                  <a:srgbClr val="FFFFFF"/>
+                  <a:srgbClr val="2B1D19"/>
                 </a:solidFill>
               </a:rPr>
               <a:t>​</a:t>
@@ -12940,36 +13158,36 @@
             <a:r>
               <a:rPr lang="en-US" sz="2000" dirty="0">
                 <a:solidFill>
-                  <a:srgbClr val="FFFFFF"/>
-                </a:solidFill>
-              </a:rPr>
-              <a:t>What does </a:t>
+                  <a:srgbClr val="2B1D19"/>
+                </a:solidFill>
+              </a:rPr>
+              <a:t>Search for </a:t>
             </a:r>
             <a:r>
               <a:rPr lang="en-US" sz="1800" b="1" dirty="0">
                 <a:solidFill>
-                  <a:srgbClr val="E8A55A"/>
+                  <a:srgbClr val="B86E1E"/>
                 </a:solidFill>
                 <a:latin typeface="Courier New" pitchFamily="34" charset="0"/>
                 <a:ea typeface="Courier New" pitchFamily="34" charset="-122"/>
                 <a:cs typeface="Courier New" pitchFamily="34" charset="-120"/>
               </a:rPr>
-              <a:t>games.shape</a:t>
+              <a:t>Hollow Knight</a:t>
             </a:r>
             <a:r>
               <a:rPr lang="en-US" sz="2000" dirty="0">
                 <a:solidFill>
-                  <a:srgbClr val="FFFFFF"/>
-                </a:solidFill>
-              </a:rPr>
-              <a:t> tell us about our data?</a:t>
+                  <a:srgbClr val="2B1D19"/>
+                </a:solidFill>
+              </a:rPr>
+              <a:t>. How would we work out what share of its reviews are positive?</a:t>
             </a:r>
             <a:endParaRPr lang="en-US" sz="2000" dirty="0"/>
           </a:p>
           <a:p>
             <a:pPr marL="342900" indent="-342900">
               <a:spcAft>
-                <a:spcPts val="1400"/>
+                <a:spcPts val="1000"/>
               </a:spcAft>
               <a:buSzPct val="100000"/>
               <a:buFont typeface="+mj-lt"/>
@@ -12978,7 +13196,7 @@
             <a:r>
               <a:rPr lang="en-US" sz="2000" dirty="0">
                 <a:solidFill>
-                  <a:srgbClr val="FFFFFF"/>
+                  <a:srgbClr val="2B1D19"/>
                 </a:solidFill>
               </a:rPr>
               <a:t>​</a:t>
@@ -12986,102 +13204,29 @@
             <a:r>
               <a:rPr lang="en-US" sz="2000" dirty="0">
                 <a:solidFill>
-                  <a:srgbClr val="FFFFFF"/>
-                </a:solidFill>
-              </a:rPr>
-              <a:t>Why is it a problem that </a:t>
+                  <a:srgbClr val="2B1D19"/>
+                </a:solidFill>
+              </a:rPr>
+              <a:t>Sort by </a:t>
             </a:r>
             <a:r>
               <a:rPr lang="en-US" sz="1800" b="1" dirty="0">
                 <a:solidFill>
-                  <a:srgbClr val="E8A55A"/>
+                  <a:srgbClr val="B86E1E"/>
                 </a:solidFill>
                 <a:latin typeface="Courier New" pitchFamily="34" charset="0"/>
                 <a:ea typeface="Courier New" pitchFamily="34" charset="-122"/>
                 <a:cs typeface="Courier New" pitchFamily="34" charset="-120"/>
               </a:rPr>
-              <a:t>Release date</a:t>
+              <a:t>Metacritic score</a:t>
             </a:r>
             <a:r>
               <a:rPr lang="en-US" sz="2000" dirty="0">
                 <a:solidFill>
-                  <a:srgbClr val="FFFFFF"/>
-                </a:solidFill>
-              </a:rPr>
-              <a:t> is a String?</a:t>
-            </a:r>
-            <a:endParaRPr lang="en-US" sz="2000" dirty="0"/>
-          </a:p>
-          <a:p>
-            <a:pPr marL="342900" indent="-342900">
-              <a:spcAft>
-                <a:spcPts val="1400"/>
-              </a:spcAft>
-              <a:buSzPct val="100000"/>
-              <a:buFont typeface="+mj-lt"/>
-              <a:buAutoNum type="arabicPeriod" startAt="1"/>
-            </a:pPr>
-            <a:r>
-              <a:rPr lang="en-US" sz="2000" dirty="0">
-                <a:solidFill>
-                  <a:srgbClr val="FFFFFF"/>
-                </a:solidFill>
-              </a:rPr>
-              <a:t>​</a:t>
-            </a:r>
-            <a:r>
-              <a:rPr lang="en-US" sz="2000" dirty="0">
-                <a:solidFill>
-                  <a:srgbClr val="FFFFFF"/>
-                </a:solidFill>
-              </a:rPr>
-              <a:t>What does it mean that marimo is reactive?</a:t>
-            </a:r>
-            <a:endParaRPr lang="en-US" sz="2000" dirty="0"/>
-          </a:p>
-          <a:p>
-            <a:pPr marL="342900" indent="-342900">
-              <a:spcAft>
-                <a:spcPts val="1400"/>
-              </a:spcAft>
-              <a:buSzPct val="100000"/>
-              <a:buFont typeface="+mj-lt"/>
-              <a:buAutoNum type="arabicPeriod" startAt="1"/>
-            </a:pPr>
-            <a:r>
-              <a:rPr lang="en-US" sz="2000" dirty="0">
-                <a:solidFill>
-                  <a:srgbClr val="FFFFFF"/>
-                </a:solidFill>
-              </a:rPr>
-              <a:t>​</a:t>
-            </a:r>
-            <a:r>
-              <a:rPr lang="en-US" sz="2000" dirty="0">
-                <a:solidFill>
-                  <a:srgbClr val="FFFFFF"/>
-                </a:solidFill>
-              </a:rPr>
-              <a:t>Why does marimo refuse to run a second cell that creates </a:t>
-            </a:r>
-            <a:r>
-              <a:rPr lang="en-US" sz="1800" b="1" dirty="0">
-                <a:solidFill>
-                  <a:srgbClr val="E8A55A"/>
-                </a:solidFill>
-                <a:latin typeface="Courier New" pitchFamily="34" charset="0"/>
-                <a:ea typeface="Courier New" pitchFamily="34" charset="-122"/>
-                <a:cs typeface="Courier New" pitchFamily="34" charset="-120"/>
-              </a:rPr>
-              <a:t>sample_size</a:t>
-            </a:r>
-            <a:r>
-              <a:rPr lang="en-US" sz="2000" dirty="0">
-                <a:solidFill>
-                  <a:srgbClr val="FFFFFF"/>
-                </a:solidFill>
-              </a:rPr>
-              <a:t>?</a:t>
+                  <a:srgbClr val="2B1D19"/>
+                </a:solidFill>
+              </a:rPr>
+              <a:t>. Are the games scoring 0 really that bad?</a:t>
             </a:r>
             <a:endParaRPr lang="en-US" sz="2000" dirty="0"/>
           </a:p>
@@ -13117,7 +13262,7 @@
             <a:lvl1pPr>
               <a:defRPr sz="1000">
                 <a:solidFill>
-                  <a:srgbClr val="F7EFE6"/>
+                  <a:srgbClr val="6B6B6B"/>
                 </a:solidFill>
               </a:defRPr>
             </a:lvl1pPr>
@@ -13159,6 +13304,328 @@
       </p:grpSpPr>
       <p:sp>
         <p:nvSpPr>
+          <p:cNvPr id="2" name="Text 0"/>
+          <p:cNvSpPr txBox="1"/>
+          <p:nvPr/>
+        </p:nvSpPr>
+        <p:spPr>
+          <a:xfrm>
+            <a:off x="457200" y="457200"/>
+            <a:ext cx="7772400" cy="365760"/>
+          </a:xfrm>
+          <a:prstGeom prst="rect">
+            <a:avLst/>
+          </a:prstGeom>
+          <a:noFill/>
+          <a:ln/>
+        </p:spPr>
+        <p:txBody>
+          <a:bodyPr wrap="square" lIns="0" tIns="0" rIns="0" bIns="0" rtlCol="0" anchor="ctr"/>
+          <a:lstStyle/>
+          <a:p>
+            <a:pPr indent="0" marL="0">
+              <a:buNone/>
+            </a:pPr>
+            <a:r>
+              <a:rPr lang="en-US" sz="1400" b="1" spc="200" kern="0" dirty="0">
+                <a:solidFill>
+                  <a:srgbClr val="E8A55A"/>
+                </a:solidFill>
+              </a:rPr>
+              <a:t>CHECK YOUR UNDERSTANDING</a:t>
+            </a:r>
+            <a:endParaRPr lang="en-US" sz="1400" dirty="0"/>
+          </a:p>
+        </p:txBody>
+      </p:sp>
+      <p:sp>
+        <p:nvSpPr>
+          <p:cNvPr id="3" name="Text 1"/>
+          <p:cNvSpPr txBox="1"/>
+          <p:nvPr/>
+        </p:nvSpPr>
+        <p:spPr>
+          <a:xfrm>
+            <a:off x="457200" y="1005840"/>
+            <a:ext cx="7498080" cy="3108960"/>
+          </a:xfrm>
+          <a:prstGeom prst="rect">
+            <a:avLst/>
+          </a:prstGeom>
+          <a:noFill/>
+          <a:ln/>
+        </p:spPr>
+        <p:txBody>
+          <a:bodyPr wrap="square" lIns="0" tIns="0" rIns="0" bIns="0" rtlCol="0" anchor="t">
+            <a:normAutofit/>
+          </a:bodyPr>
+          <a:lstStyle/>
+          <a:p>
+            <a:pPr marL="342900" indent="-342900">
+              <a:spcAft>
+                <a:spcPts val="1400"/>
+              </a:spcAft>
+              <a:buSzPct val="100000"/>
+              <a:buFont typeface="+mj-lt"/>
+              <a:buAutoNum type="arabicPeriod" startAt="1"/>
+            </a:pPr>
+            <a:r>
+              <a:rPr lang="en-US" sz="2000" dirty="0">
+                <a:solidFill>
+                  <a:srgbClr val="FFFFFF"/>
+                </a:solidFill>
+              </a:rPr>
+              <a:t>​</a:t>
+            </a:r>
+            <a:r>
+              <a:rPr lang="en-US" sz="2000" dirty="0">
+                <a:solidFill>
+                  <a:srgbClr val="FFFFFF"/>
+                </a:solidFill>
+              </a:rPr>
+              <a:t>Where does a marimo cell's output appear?</a:t>
+            </a:r>
+            <a:endParaRPr lang="en-US" sz="2000" dirty="0"/>
+          </a:p>
+          <a:p>
+            <a:pPr marL="342900" indent="-342900">
+              <a:spcAft>
+                <a:spcPts val="1400"/>
+              </a:spcAft>
+              <a:buSzPct val="100000"/>
+              <a:buFont typeface="+mj-lt"/>
+              <a:buAutoNum type="arabicPeriod" startAt="1"/>
+            </a:pPr>
+            <a:r>
+              <a:rPr lang="en-US" sz="2000" dirty="0">
+                <a:solidFill>
+                  <a:srgbClr val="FFFFFF"/>
+                </a:solidFill>
+              </a:rPr>
+              <a:t>​</a:t>
+            </a:r>
+            <a:r>
+              <a:rPr lang="en-US" sz="2000" dirty="0">
+                <a:solidFill>
+                  <a:srgbClr val="FFFFFF"/>
+                </a:solidFill>
+              </a:rPr>
+              <a:t>What does </a:t>
+            </a:r>
+            <a:r>
+              <a:rPr lang="en-US" sz="1800" b="1" dirty="0">
+                <a:solidFill>
+                  <a:srgbClr val="E8A55A"/>
+                </a:solidFill>
+                <a:latin typeface="Courier New" pitchFamily="34" charset="0"/>
+                <a:ea typeface="Courier New" pitchFamily="34" charset="-122"/>
+                <a:cs typeface="Courier New" pitchFamily="34" charset="-120"/>
+              </a:rPr>
+              <a:t>games.shape</a:t>
+            </a:r>
+            <a:r>
+              <a:rPr lang="en-US" sz="2000" dirty="0">
+                <a:solidFill>
+                  <a:srgbClr val="FFFFFF"/>
+                </a:solidFill>
+              </a:rPr>
+              <a:t> tell us about our data?</a:t>
+            </a:r>
+            <a:endParaRPr lang="en-US" sz="2000" dirty="0"/>
+          </a:p>
+          <a:p>
+            <a:pPr marL="342900" indent="-342900">
+              <a:spcAft>
+                <a:spcPts val="1400"/>
+              </a:spcAft>
+              <a:buSzPct val="100000"/>
+              <a:buFont typeface="+mj-lt"/>
+              <a:buAutoNum type="arabicPeriod" startAt="1"/>
+            </a:pPr>
+            <a:r>
+              <a:rPr lang="en-US" sz="2000" dirty="0">
+                <a:solidFill>
+                  <a:srgbClr val="FFFFFF"/>
+                </a:solidFill>
+              </a:rPr>
+              <a:t>​</a:t>
+            </a:r>
+            <a:r>
+              <a:rPr lang="en-US" sz="2000" dirty="0">
+                <a:solidFill>
+                  <a:srgbClr val="FFFFFF"/>
+                </a:solidFill>
+              </a:rPr>
+              <a:t>Why is it a problem that </a:t>
+            </a:r>
+            <a:r>
+              <a:rPr lang="en-US" sz="1800" b="1" dirty="0">
+                <a:solidFill>
+                  <a:srgbClr val="E8A55A"/>
+                </a:solidFill>
+                <a:latin typeface="Courier New" pitchFamily="34" charset="0"/>
+                <a:ea typeface="Courier New" pitchFamily="34" charset="-122"/>
+                <a:cs typeface="Courier New" pitchFamily="34" charset="-120"/>
+              </a:rPr>
+              <a:t>Release date</a:t>
+            </a:r>
+            <a:r>
+              <a:rPr lang="en-US" sz="2000" dirty="0">
+                <a:solidFill>
+                  <a:srgbClr val="FFFFFF"/>
+                </a:solidFill>
+              </a:rPr>
+              <a:t> is a String?</a:t>
+            </a:r>
+            <a:endParaRPr lang="en-US" sz="2000" dirty="0"/>
+          </a:p>
+          <a:p>
+            <a:pPr marL="342900" indent="-342900">
+              <a:spcAft>
+                <a:spcPts val="1400"/>
+              </a:spcAft>
+              <a:buSzPct val="100000"/>
+              <a:buFont typeface="+mj-lt"/>
+              <a:buAutoNum type="arabicPeriod" startAt="1"/>
+            </a:pPr>
+            <a:r>
+              <a:rPr lang="en-US" sz="2000" dirty="0">
+                <a:solidFill>
+                  <a:srgbClr val="FFFFFF"/>
+                </a:solidFill>
+              </a:rPr>
+              <a:t>​</a:t>
+            </a:r>
+            <a:r>
+              <a:rPr lang="en-US" sz="2000" dirty="0">
+                <a:solidFill>
+                  <a:srgbClr val="FFFFFF"/>
+                </a:solidFill>
+              </a:rPr>
+              <a:t>What does it mean that marimo is reactive?</a:t>
+            </a:r>
+            <a:endParaRPr lang="en-US" sz="2000" dirty="0"/>
+          </a:p>
+          <a:p>
+            <a:pPr marL="342900" indent="-342900">
+              <a:spcAft>
+                <a:spcPts val="1400"/>
+              </a:spcAft>
+              <a:buSzPct val="100000"/>
+              <a:buFont typeface="+mj-lt"/>
+              <a:buAutoNum type="arabicPeriod" startAt="1"/>
+            </a:pPr>
+            <a:r>
+              <a:rPr lang="en-US" sz="2000" dirty="0">
+                <a:solidFill>
+                  <a:srgbClr val="FFFFFF"/>
+                </a:solidFill>
+              </a:rPr>
+              <a:t>​</a:t>
+            </a:r>
+            <a:r>
+              <a:rPr lang="en-US" sz="2000" dirty="0">
+                <a:solidFill>
+                  <a:srgbClr val="FFFFFF"/>
+                </a:solidFill>
+              </a:rPr>
+              <a:t>Why does marimo refuse to run a second cell that creates </a:t>
+            </a:r>
+            <a:r>
+              <a:rPr lang="en-US" sz="1800" b="1" dirty="0">
+                <a:solidFill>
+                  <a:srgbClr val="E8A55A"/>
+                </a:solidFill>
+                <a:latin typeface="Courier New" pitchFamily="34" charset="0"/>
+                <a:ea typeface="Courier New" pitchFamily="34" charset="-122"/>
+                <a:cs typeface="Courier New" pitchFamily="34" charset="-120"/>
+              </a:rPr>
+              <a:t>sample_size</a:t>
+            </a:r>
+            <a:r>
+              <a:rPr lang="en-US" sz="2000" dirty="0">
+                <a:solidFill>
+                  <a:srgbClr val="FFFFFF"/>
+                </a:solidFill>
+              </a:rPr>
+              <a:t>?</a:t>
+            </a:r>
+            <a:endParaRPr lang="en-US" sz="2000" dirty="0"/>
+          </a:p>
+        </p:txBody>
+      </p:sp>
+      <p:sp>
+        <p:nvSpPr>
+          <p:cNvPr id="25" name="Slide Number Placeholder 0"/>
+          <p:cNvSpPr>
+            <a:spLocks noGrp="1"/>
+          </p:cNvSpPr>
+          <p:nvPr>
+            <p:ph type="sldNum" sz="quarter" idx="4294967295"/>
+          </p:nvPr>
+        </p:nvSpPr>
+        <p:spPr>
+          <a:xfrm>
+            <a:off x="365760" y="4709160"/>
+            <a:ext cx="548640" cy="274320"/>
+          </a:xfrm>
+          <a:prstGeom prst="rect">
+            <a:avLst/>
+          </a:prstGeom>
+          <a:extLst>
+            <a:ext uri="{C572A759-6A51-4108-AA02-DFA0A04FC94B}">
+              <ma14:wrappingTextBoxFlag xmlns:ma14="http://schemas.microsoft.com/office/mac/drawingml/2011/main" val="0"/>
+            </a:ext>
+          </a:extLst>
+        </p:spPr>
+        <p:txBody>
+          <a:bodyPr/>
+          <a:lstStyle>
+            <a:lvl1pPr>
+              <a:defRPr sz="1000">
+                <a:solidFill>
+                  <a:srgbClr val="F7EFE6"/>
+                </a:solidFill>
+              </a:defRPr>
+            </a:lvl1pPr>
+          </a:lstStyle>
+          <a:p>
+            <a:pPr algn="l"/>
+            <a:fld id="{F7021451-1387-4CA6-816F-3879F97B5CBC}" type="slidenum">
+              <a:rPr b="0" lang="en-US"/>
+              <a:t>32</a:t>
+            </a:fld>
+            <a:endParaRPr lang="en-US"/>
+          </a:p>
+        </p:txBody>
+      </p:sp>
+    </p:spTree>
+  </p:cSld>
+  <p:clrMapOvr>
+    <a:masterClrMapping/>
+  </p:clrMapOvr>
+</p:sld>
+</file>
+
+<file path=ppt/slides/slide33.xml><?xml version="1.0" encoding="utf-8"?>
+<p:sld xmlns:a="http://schemas.openxmlformats.org/drawingml/2006/main" xmlns:r="http://schemas.openxmlformats.org/officeDocument/2006/relationships" xmlns:p="http://schemas.openxmlformats.org/presentationml/2006/main">
+  <p:cSld name="Slide 33">
+    <p:spTree>
+      <p:nvGrpSpPr>
+        <p:cNvPr id="1" name=""/>
+        <p:cNvGrpSpPr/>
+        <p:nvPr/>
+      </p:nvGrpSpPr>
+      <p:grpSpPr>
+        <a:xfrm>
+          <a:off x="0" y="0"/>
+          <a:ext cx="0" cy="0"/>
+          <a:chOff x="0" y="0"/>
+          <a:chExt cx="0" cy="0"/>
+        </a:xfrm>
+      </p:grpSpPr>
+      <p:sp>
+        <p:nvSpPr>
           <p:cNvPr id="2" name="Title"/>
           <p:cNvSpPr txBox="1"/>
           <p:nvPr/>
@@ -13443,7 +13910,7 @@
             <a:pPr algn="l"/>
             <a:fld id="{F7021451-1387-4CA6-816F-3879F97B5CBC}" type="slidenum">
               <a:rPr b="0" lang="en-US"/>
-              <a:t>32</a:t>
+              <a:t>33</a:t>
             </a:fld>
             <a:endParaRPr lang="en-US"/>
           </a:p>

</xml_diff>